<commit_message>
docs(guide): 25 pages in 6 tabs; storyline and slide-rules reference
- The guide is split into pages (one per step) inside one emailed file, with
  a whole-guide view for search and printing; old links keep working
- New Storylines and Slide rules pages, every rule sourced from the skills
  and shown with why, do / don't and where it is checked
- check_tutorial.py checks the type-scale numbers against type_scale.py and
  buzzword examples against banned-words.md
- Meridian slide 8 reworded to what its data supports and rebuilt

Co-Authored-By: Claude Opus 5.5 <noreply@anthropic.com>
</commit_message>
<xml_diff>
--- a/Slide-Lab-Example-Deck.pptx
+++ b/Slide-Lab-Example-Deck.pptx
@@ -548,6 +548,11 @@
           <a:p>
             <a:r>
               <a:t>- Quality check: no Critical or Major findings; 3 Advisory notes. The deck also opened cleanly in PowerPoint.</a:t>
+            </a:r>
+          </a:p>
+          <a:p>
+            <a:r>
+              <a:t>- 6 October: slide 8's headline was reworded to say what the data supports ("We expect partners to lower Indonesia's entry cost; no data yet") and that one slide redesigned in one design, keeping the picked layout.</a:t>
             </a:r>
           </a:p>
           <a:p>
@@ -19328,7 +19333,7 @@
       <p:grpSpPr/>
       <p:sp>
         <p:nvSpPr>
-          <p:cNvPr id="43" name="Title 1"/>
+          <p:cNvPr id="44" name="Title 1"/>
           <p:cNvSpPr>
             <a:spLocks noGrp="1"/>
           </p:cNvSpPr>
@@ -19346,7 +19351,7 @@
             </a:pPr>
             <a:r>
               <a:rPr sz="2800"/>
-              <a:t>Each new partner makes the next market cheaper to enter</a:t>
+              <a:t>We expect partners to lower Indonesia's entry cost; no data yet</a:t>
             </a:r>
           </a:p>
         </p:txBody>
@@ -19410,7 +19415,7 @@
       </p:sp>
       <p:sp>
         <p:nvSpPr>
-          <p:cNvPr id="40" name="subtitle"/>
+          <p:cNvPr id="41" name="subtitle"/>
           <p:cNvSpPr txBox="1"/>
           <p:nvPr/>
         </p:nvSpPr>
@@ -19450,7 +19455,7 @@
       </p:sp>
       <p:cxnSp>
         <p:nvCxnSpPr>
-          <p:cNvPr id="44" name="Connector 2"/>
+          <p:cNvPr id="45" name="Connector 2"/>
           <p:cNvCxnSpPr/>
           <p:nvPr/>
         </p:nvCxnSpPr>
@@ -19520,7 +19525,7 @@
       </p:cxnSp>
       <p:cxnSp>
         <p:nvCxnSpPr>
-          <p:cNvPr id="41" name="Connector 4"/>
+          <p:cNvPr id="42" name="Connector 4"/>
           <p:cNvCxnSpPr/>
           <p:nvPr/>
         </p:nvCxnSpPr>
@@ -19555,7 +19560,7 @@
       </p:cxnSp>
       <p:cxnSp>
         <p:nvCxnSpPr>
-          <p:cNvPr id="42" name="Connector 5"/>
+          <p:cNvPr id="43" name="Connector 5"/>
           <p:cNvCxnSpPr/>
           <p:nvPr/>
         </p:nvCxnSpPr>
@@ -20993,7 +20998,7 @@
                 </a:solidFill>
                 <a:latin typeface="+mj-lt"/>
               </a:rPr>
-              <a:t>The next market starts from proven choices, so it costs less to enter, which attracts more partners</a:t>
+              <a:t>The next market starts from proven choices, so it should cost less to enter, which attracts more partners</a:t>
             </a:r>
           </a:p>
         </p:txBody>
@@ -21053,8 +21058,8 @@
         </p:nvSpPr>
         <p:spPr>
           <a:xfrm>
-            <a:off x="4619625" y="3919738"/>
-            <a:ext cx="2952750" cy="547287"/>
+            <a:off x="4524375" y="3748288"/>
+            <a:ext cx="3143250" cy="547287"/>
           </a:xfrm>
           <a:prstGeom prst="rect">
             <a:avLst/>
@@ -21080,7 +21085,47 @@
                 </a:solidFill>
                 <a:latin typeface="+mj-lt"/>
               </a:rPr>
-              <a:t>Each new partner makes the next market cheaper to enter</a:t>
+              <a:t>We expect partners to lower Indonesia's entry cost;</a:t>
+            </a:r>
+          </a:p>
+        </p:txBody>
+      </p:sp>
+      <p:sp>
+        <p:nvSpPr>
+          <p:cNvPr id="40" name="loop-hub-nodata"/>
+          <p:cNvSpPr txBox="1"/>
+          <p:nvPr/>
+        </p:nvSpPr>
+        <p:spPr>
+          <a:xfrm>
+            <a:off x="4524375" y="4337498"/>
+            <a:ext cx="3143101" cy="283169"/>
+          </a:xfrm>
+          <a:prstGeom prst="rect">
+            <a:avLst/>
+          </a:prstGeom>
+          <a:noFill/>
+        </p:spPr>
+        <p:txBody>
+          <a:bodyPr wrap="none" lIns="0" rIns="0" tIns="0" bIns="0" anchor="t">
+            <a:noAutofit/>
+          </a:bodyPr>
+          <a:lstStyle/>
+          <a:p>
+            <a:pPr algn="ctr">
+              <a:lnSpc>
+                <a:spcPts val="2079"/>
+              </a:lnSpc>
+              <a:defRPr/>
+            </a:pPr>
+            <a:r>
+              <a:rPr sz="1600" b="1" i="0">
+                <a:solidFill>
+                  <a:schemeClr val="tx2"/>
+                </a:solidFill>
+                <a:latin typeface="+mj-lt"/>
+              </a:rPr>
+              <a:t>no data yet</a:t>
             </a:r>
           </a:p>
         </p:txBody>

</xml_diff>